<commit_message>
Judge and score v2 runs for composer-2.5, gemini-3.1-pro, gemini-3.8-flash; findings and recommendation
Co-authored-by: Audge <audr3x@users.noreply.github.com>
</commit_message>
<xml_diff>
--- a/evals/runs/gemini-3.8-flash/T07-unsupported-slides/preview.pptx
+++ b/evals/runs/gemini-3.8-flash/T07-unsupported-slides/preview.pptx
@@ -317,15 +317,75 @@
             </c:strRef>
           </c:tx>
           <c:spPr>
-            <a:solidFill>
-              <a:srgbClr val="1C98E8"/>
-            </a:solidFill>
             <a:ln>
+              <a:solidFill>
+                <a:srgbClr val="FFFFFF"/>
+              </a:solidFill>
+            </a:ln>
+          </c:spPr>
+          <c:dPt>
+            <c:idx val="0"/>
+            <c:spPr>
               <a:solidFill>
                 <a:srgbClr val="1C98E8"/>
               </a:solidFill>
-            </a:ln>
-          </c:spPr>
+              <a:ln>
+                <a:solidFill>
+                  <a:srgbClr val="FFFFFF"/>
+                </a:solidFill>
+              </a:ln>
+            </c:spPr>
+          </c:dPt>
+          <c:dPt>
+            <c:idx val="1"/>
+            <c:spPr>
+              <a:solidFill>
+                <a:srgbClr val="FEC10B"/>
+              </a:solidFill>
+              <a:ln>
+                <a:solidFill>
+                  <a:srgbClr val="FFFFFF"/>
+                </a:solidFill>
+              </a:ln>
+            </c:spPr>
+          </c:dPt>
+          <c:dPt>
+            <c:idx val="2"/>
+            <c:spPr>
+              <a:solidFill>
+                <a:srgbClr val="0057AE"/>
+              </a:solidFill>
+              <a:ln>
+                <a:solidFill>
+                  <a:srgbClr val="FFFFFF"/>
+                </a:solidFill>
+              </a:ln>
+            </c:spPr>
+          </c:dPt>
+          <c:dLbls>
+            <c:txPr>
+              <a:bodyPr/>
+              <a:lstStyle/>
+              <a:p>
+                <a:pPr>
+                  <a:defRPr sz="1200">
+                    <a:solidFill>
+                      <a:srgbClr val="0F2E66"/>
+                    </a:solidFill>
+                    <a:latin typeface="Archivo Light"/>
+                  </a:defRPr>
+                </a:pPr>
+              </a:p>
+            </c:txPr>
+            <c:dLblPos val="outEnd"/>
+            <c:showLegendKey val="0"/>
+            <c:showVal val="1"/>
+            <c:showCatName val="0"/>
+            <c:showSerName val="0"/>
+            <c:showPercent val="0"/>
+            <c:showBubbleSize val="0"/>
+            <c:showLeaderLines val="1"/>
+          </c:dLbls>
           <c:cat>
             <c:strRef>
               <c:f>Sheet1!$A$2:$A$4</c:f>
@@ -362,8 +422,35 @@
             </c:numRef>
           </c:val>
         </c:ser>
+        <c:dLbls>
+          <c:showLegendKey val="0"/>
+          <c:showVal val="1"/>
+          <c:showCatName val="0"/>
+          <c:showSerName val="0"/>
+          <c:showPercent val="0"/>
+          <c:showBubbleSize val="0"/>
+          <c:showLeaderLines val="1"/>
+        </c:dLbls>
       </c:pieChart>
     </c:plotArea>
+    <c:legend>
+      <c:legendPos/>
+      <c:overlay val="1"/>
+      <c:txPr>
+        <a:bodyPr/>
+        <a:lstStyle/>
+        <a:p>
+          <a:pPr>
+            <a:defRPr sz="1000">
+              <a:solidFill>
+                <a:srgbClr val="0F2E66"/>
+              </a:solidFill>
+              <a:latin typeface="Archivo"/>
+            </a:defRPr>
+          </a:pPr>
+        </a:p>
+      </c:txPr>
+    </c:legend>
     <c:dispBlanksAs val="gap"/>
   </c:chart>
   <c:txPr>

</xml_diff>